<commit_message>
fix(F111): keep the gov-red cover rings clear of the title
Co-Authored-By: Claude Opus 5.5 <noreply@anthropic.com>
</commit_message>
<xml_diff>
--- a/src/backend/bisheng/linsight/builtin_skills/bisheng-pptx/templates/gov-red/template.pptx
+++ b/src/backend/bisheng/linsight/builtin_skills/bisheng-pptx/templates/gov-red/template.pptx
@@ -2066,8 +2066,8 @@
         </p:nvSpPr>
         <p:spPr>
           <a:xfrm>
-            <a:off x="6858000" y="457200"/>
-            <a:ext cx="5080000" cy="5080000"/>
+            <a:off x="7366000" y="635000"/>
+            <a:ext cx="4572000" cy="4572000"/>
           </a:xfrm>
           <a:prstGeom prst="ellipse">
             <a:avLst/>
@@ -2108,8 +2108,8 @@
         </p:nvSpPr>
         <p:spPr>
           <a:xfrm>
-            <a:off x="7874000" y="1473200"/>
-            <a:ext cx="3048000" cy="3048000"/>
+            <a:off x="8255000" y="1524000"/>
+            <a:ext cx="2794000" cy="2794000"/>
           </a:xfrm>
           <a:prstGeom prst="ellipse">
             <a:avLst/>
@@ -2151,7 +2151,7 @@
         <p:spPr>
           <a:xfrm>
             <a:off x="914400" y="1498600"/>
-            <a:ext cx="6604000" cy="254000"/>
+            <a:ext cx="6096000" cy="254000"/>
           </a:xfrm>
           <a:prstGeom prst="rect">
             <a:avLst/>
@@ -2191,7 +2191,7 @@
         <p:spPr>
           <a:xfrm>
             <a:off x="914400" y="2057400"/>
-            <a:ext cx="6604000" cy="1651000"/>
+            <a:ext cx="6096000" cy="1651000"/>
           </a:xfrm>
           <a:prstGeom prst="rect">
             <a:avLst/>
@@ -2231,7 +2231,7 @@
         <p:spPr>
           <a:xfrm>
             <a:off x="914400" y="3886200"/>
-            <a:ext cx="6604000" cy="660400"/>
+            <a:ext cx="6096000" cy="660400"/>
           </a:xfrm>
           <a:prstGeom prst="rect">
             <a:avLst/>
@@ -7817,8 +7817,8 @@
         </p:nvSpPr>
         <p:spPr>
           <a:xfrm>
-            <a:off x="6858000" y="457200"/>
-            <a:ext cx="5080000" cy="5080000"/>
+            <a:off x="7366000" y="635000"/>
+            <a:ext cx="4572000" cy="4572000"/>
           </a:xfrm>
           <a:prstGeom prst="ellipse">
             <a:avLst/>
@@ -7859,8 +7859,8 @@
         </p:nvSpPr>
         <p:spPr>
           <a:xfrm>
-            <a:off x="7874000" y="1473200"/>
-            <a:ext cx="3048000" cy="3048000"/>
+            <a:off x="8255000" y="1524000"/>
+            <a:ext cx="2794000" cy="2794000"/>
           </a:xfrm>
           <a:prstGeom prst="ellipse">
             <a:avLst/>
@@ -8805,8 +8805,8 @@
         </p:nvSpPr>
         <p:spPr>
           <a:xfrm>
-            <a:off x="6858000" y="457200"/>
-            <a:ext cx="5080000" cy="5080000"/>
+            <a:off x="7366000" y="635000"/>
+            <a:ext cx="4572000" cy="4572000"/>
           </a:xfrm>
           <a:prstGeom prst="ellipse">
             <a:avLst/>
@@ -8847,8 +8847,8 @@
         </p:nvSpPr>
         <p:spPr>
           <a:xfrm>
-            <a:off x="7874000" y="1473200"/>
-            <a:ext cx="3048000" cy="3048000"/>
+            <a:off x="8255000" y="1524000"/>
+            <a:ext cx="2794000" cy="2794000"/>
           </a:xfrm>
           <a:prstGeom prst="ellipse">
             <a:avLst/>

</xml_diff>